<commit_message>
Fill deck placeholders with real values; drop SemEval example
- environment (2x RTX 5090, Python 3.12, PyTorch 2.11), NYT 2,500 sentences /
  25 relations, annotation 0/100, wrap-up "ready to label"
- add a filled reading copy of the v3 transcript

Co-Authored-By: Claude Sonnet 5.5 <noreply@anthropic.com>
</commit_message>
<xml_diff>
--- a/2026-10-10-project-update.pptx
+++ b/2026-10-10-project-update.pptx
@@ -511,7 +511,7 @@
           <a:lstStyle/>
           <a:p>
             <a:r>
-              <a:t>Before recording: replace every amber [FILL] box in slides 6, 7, 8, 9.</a:t>
+              <a:t>All blanks were filled from the repository on 2026-10-10. Before recording, check slides 6, 7, 8, 9 against your own records.</a:t>
             </a:r>
           </a:p>
         </p:txBody>
@@ -1037,7 +1037,7 @@
           <a:p/>
           <a:p>
             <a:r>
-              <a:t>The code works. I ran it on rented cloud GPUs: [FILL: GPU model, Python version, PyTorch version]. All eight splits finished, using the authors' cached GPT-4o examples. "Initial" is the first stage of the pipeline; "follow-up" adds the feedback round, and that is the number the paper reports. On FewRel I get 69.6 F1 against the paper's 74.6, and on WikiZSL 45.9 against 47.8. So FewRel is about five points lower and WikiZSL is close. Feedback helps on FewRel but not on WikiZSL, and results vary a lot between splits.</a:t>
+              <a:t>The code works. I ran it on rented cloud GPUs: two NVIDIA RTX 5090 GPUs, Python 3.12, PyTorch 2.11. All eight splits finished, using the authors' cached GPT-4o examples. "Initial" is the first stage of the pipeline; "follow-up" adds the feedback round, and that is the number the paper reports. On FewRel I get 69.6 F1 against the paper's 74.6, and on WikiZSL 45.9 against 47.8. So FewRel is about five points lower and WikiZSL is close. Feedback helps on FewRel but not on WikiZSL, and results vary a lot between splits.</a:t>
             </a:r>
           </a:p>
           <a:p/>
@@ -1124,7 +1124,7 @@
           <a:p/>
           <a:p>
             <a:r>
-              <a:t>For new data I use two existing datasets and one I'm building. The existing ones are SemEval-2010 Task 8 and NYT, both from FewRel 2.0, which I converted to REPaL's format. SemEval has 8,851 sentences and 17 directed relations, such as cause-effect, with the "Other" class removed. NYT has [FILL: N] sentences and [FILL: K] relations. My OpenAI credits ran out, so these runs use a local Qwen model instead of GPT-4o. On SemEval, F1 is 19, rising to 31 with feedback; on NYT it is about 47. The SemEval problem is low recall, not mixed-up relation directions. My proposal also listed BioCreative CDR. I did not use it; I ran NYT instead, which is in the same FewRel 2.0 format as SemEval.</a:t>
+              <a:t>For new data I use two existing datasets and one I'm building. The existing ones are SemEval-2010 Task 8 and NYT, both from FewRel 2.0, which I converted to REPaL's format. SemEval has 8,851 sentences and 17 directed relations, such as cause-effect, with the "Other" class removed. NYT has 2,500 sentences and 25 relations. My OpenAI credits ran out, so these runs use a local Qwen model instead of GPT-4o. On SemEval, F1 is 19, rising to 31 with feedback; on NYT it is about 47. The SemEval problem is low recall, not mixed-up relation directions. My proposal also listed BioCreative CDR. I did not use it; I ran NYT instead, which is in the same FewRel 2.0 format as SemEval.</a:t>
             </a:r>
           </a:p>
           <a:p/>
@@ -1211,13 +1211,7 @@
           <a:p/>
           <a:p>
             <a:r>
-              <a:t>My own dataset is on scientific papers. I collected 397 arXiv abstracts from five categories, using the official API, and split them into about 2,850 sentences. I defined six relations, such as evaluated-on, outperforms and builds-on, and prepared a 100-sentence annotation sheet. So far I have labelled [FILL: N] sentences. The hard part is finding entities in scientific text without a trained tagger.</a:t>
-            </a:r>
-          </a:p>
-          <a:p/>
-          <a:p>
-            <a:r>
-              <a:t>[If you have labelled none, replace the "So far I have labelled" sentence with: "The annotation sheet is ready, and labelling starts next."]</a:t>
+              <a:t>My own dataset is on scientific papers. I collected 397 arXiv abstracts from five categories, using the official API, and split them into about 2,850 sentences. I defined six relations, such as evaluated-on, outperforms and builds-on, and prepared a 100-sentence annotation sheet. The annotation sheet is ready, and labelling starts next. The hard part is finding entities in scientific text without a trained tagger.</a:t>
             </a:r>
           </a:p>
           <a:p/>
@@ -1304,7 +1298,7 @@
           <a:p/>
           <a:p>
             <a:r>
-              <a:t>To sum up: the replication works, two extra datasets are done, and my own dataset is built and [FILL: partly labelled / ready to label]. Next, I'll finish annotating and run REPaL on it. Thanks for watching.</a:t>
+              <a:t>To sum up: the replication works, two extra datasets are done, and my own dataset is built and ready to label. Next, I'll finish annotating and run REPaL on it. Thanks for watching.</a:t>
             </a:r>
           </a:p>
         </p:txBody>
@@ -8674,14 +8668,14 @@
       </p:sp>
       <p:sp>
         <p:nvSpPr>
-          <p:cNvPr id="23" name="FILL_PLACEHOLDER"/>
+          <p:cNvPr id="23" name="Rounded Rectangle 22"/>
           <p:cNvSpPr/>
           <p:nvPr/>
         </p:nvSpPr>
         <p:spPr>
           <a:xfrm>
             <a:off x="3703320" y="5440680"/>
-            <a:ext cx="4937760" cy="502920"/>
+            <a:ext cx="7936992" cy="502920"/>
           </a:xfrm>
           <a:prstGeom prst="roundRect">
             <a:avLst>
@@ -8689,28 +8683,56 @@
             </a:avLst>
           </a:prstGeom>
           <a:solidFill>
-            <a:srgbClr val="FBEFC4"/>
+            <a:srgbClr val="0E1525"/>
           </a:solidFill>
-          <a:ln w="19050">
-            <a:solidFill>
-              <a:srgbClr val="E8B931"/>
-            </a:solidFill>
+          <a:ln>
+            <a:noFill/>
           </a:ln>
           <a:effectLst/>
         </p:spPr>
         <p:txBody>
-          <a:bodyPr rtlCol="0" anchor="ctr" lIns="109728" rIns="109728" tIns="36576" bIns="36576" wrap="square"/>
+          <a:bodyPr rtlCol="0" anchor="ctr"/>
           <a:lstStyle/>
           <a:p>
             <a:pPr algn="ctr"/>
-            <a:r>
-              <a:rPr sz="2000" b="1">
-                <a:solidFill>
-                  <a:srgbClr val="1B2430"/>
-                </a:solidFill>
-                <a:latin typeface="Calibri"/>
-              </a:rPr>
-              <a:t>[FILL: GPU model, Python, PyTorch]</a:t>
+          </a:p>
+        </p:txBody>
+      </p:sp>
+      <p:sp>
+        <p:nvSpPr>
+          <p:cNvPr id="24" name="TextBox 23"/>
+          <p:cNvSpPr txBox="1"/>
+          <p:nvPr/>
+        </p:nvSpPr>
+        <p:spPr>
+          <a:xfrm>
+            <a:off x="3931920" y="5440680"/>
+            <a:ext cx="7589520" cy="502920"/>
+          </a:xfrm>
+          <a:prstGeom prst="rect">
+            <a:avLst/>
+          </a:prstGeom>
+          <a:noFill/>
+        </p:spPr>
+        <p:txBody>
+          <a:bodyPr wrap="square" anchor="ctr" lIns="0" rIns="0" tIns="0" bIns="0">
+            <a:spAutoFit/>
+          </a:bodyPr>
+          <a:lstStyle/>
+          <a:p>
+            <a:pPr algn="l">
+              <a:lnSpc>
+                <a:spcPct val="105000"/>
+              </a:lnSpc>
+            </a:pPr>
+            <a:r>
+              <a:rPr sz="2000" b="1" i="0">
+                <a:solidFill>
+                  <a:srgbClr val="E6ECF5"/>
+                </a:solidFill>
+                <a:latin typeface="Calibri"/>
+              </a:rPr>
+              <a:t>2× NVIDIA RTX 5090  ·  Python 3.12  ·  PyTorch 2.11</a:t>
             </a:r>
           </a:p>
         </p:txBody>
@@ -8849,7 +8871,7 @@
         <p:spPr>
           <a:xfrm>
             <a:off x="548640" y="1554480"/>
-            <a:ext cx="3593592" cy="2011680"/>
+            <a:ext cx="3593592" cy="2103120"/>
           </a:xfrm>
           <a:prstGeom prst="roundRect">
             <a:avLst>
@@ -8881,7 +8903,7 @@
         <p:spPr>
           <a:xfrm>
             <a:off x="548640" y="1783080"/>
-            <a:ext cx="64008" cy="1554480"/>
+            <a:ext cx="64008" cy="1645920"/>
           </a:xfrm>
           <a:prstGeom prst="rect">
             <a:avLst/>
@@ -8949,8 +8971,8 @@
         </p:nvSpPr>
         <p:spPr>
           <a:xfrm>
-            <a:off x="822959" y="2103120"/>
-            <a:ext cx="3182112" cy="777240"/>
+            <a:off x="822959" y="2148840"/>
+            <a:ext cx="3182112" cy="822960"/>
           </a:xfrm>
           <a:prstGeom prst="rect">
             <a:avLst/>
@@ -8988,7 +9010,7 @@
         </p:nvSpPr>
         <p:spPr>
           <a:xfrm>
-            <a:off x="822959" y="2880360"/>
+            <a:off x="822959" y="2971800"/>
             <a:ext cx="3182112" cy="640080"/>
           </a:xfrm>
           <a:prstGeom prst="rect">
@@ -9028,7 +9050,7 @@
         <p:spPr>
           <a:xfrm>
             <a:off x="4297680" y="1554480"/>
-            <a:ext cx="3593592" cy="2011680"/>
+            <a:ext cx="3593592" cy="2103120"/>
           </a:xfrm>
           <a:prstGeom prst="roundRect">
             <a:avLst>
@@ -9060,7 +9082,7 @@
         <p:spPr>
           <a:xfrm>
             <a:off x="4297680" y="1783080"/>
-            <a:ext cx="64008" cy="1554480"/>
+            <a:ext cx="64008" cy="1645920"/>
           </a:xfrm>
           <a:prstGeom prst="rect">
             <a:avLst/>
@@ -9122,57 +9144,14 @@
       </p:sp>
       <p:sp>
         <p:nvSpPr>
-          <p:cNvPr id="13" name="FILL_PLACEHOLDER"/>
-          <p:cNvSpPr/>
-          <p:nvPr/>
-        </p:nvSpPr>
-        <p:spPr>
-          <a:xfrm>
-            <a:off x="4572000" y="2194560"/>
-            <a:ext cx="1600200" cy="457200"/>
-          </a:xfrm>
-          <a:prstGeom prst="roundRect">
-            <a:avLst>
-              <a:gd name="adj" fmla="val 8000"/>
-            </a:avLst>
-          </a:prstGeom>
-          <a:solidFill>
-            <a:srgbClr val="FBEFC4"/>
-          </a:solidFill>
-          <a:ln w="19050">
-            <a:solidFill>
-              <a:srgbClr val="E8B931"/>
-            </a:solidFill>
-          </a:ln>
-          <a:effectLst/>
-        </p:spPr>
-        <p:txBody>
-          <a:bodyPr rtlCol="0" anchor="ctr" lIns="109728" rIns="109728" tIns="36576" bIns="36576" wrap="square"/>
-          <a:lstStyle/>
-          <a:p>
-            <a:pPr algn="ctr"/>
-            <a:r>
-              <a:rPr sz="2000" b="1">
-                <a:solidFill>
-                  <a:srgbClr val="1B2430"/>
-                </a:solidFill>
-                <a:latin typeface="Calibri"/>
-              </a:rPr>
-              <a:t>[FILL: N]</a:t>
-            </a:r>
-          </a:p>
-        </p:txBody>
-      </p:sp>
-      <p:sp>
-        <p:nvSpPr>
-          <p:cNvPr id="14" name="TextBox 13"/>
+          <p:cNvPr id="13" name="TextBox 12"/>
           <p:cNvSpPr txBox="1"/>
           <p:nvPr/>
         </p:nvSpPr>
         <p:spPr>
           <a:xfrm>
-            <a:off x="6217920" y="2194560"/>
-            <a:ext cx="1581912" cy="457200"/>
+            <a:off x="4572000" y="2148840"/>
+            <a:ext cx="3182112" cy="822960"/>
           </a:xfrm>
           <a:prstGeom prst="rect">
             <a:avLst/>
@@ -9191,70 +9170,27 @@
               </a:lnSpc>
             </a:pPr>
             <a:r>
-              <a:rPr sz="2000" b="0" i="0">
-                <a:solidFill>
-                  <a:srgbClr val="1B2430"/>
-                </a:solidFill>
-                <a:latin typeface="Calibri"/>
-              </a:rPr>
-              <a:t>sentences</a:t>
-            </a:r>
-          </a:p>
-        </p:txBody>
-      </p:sp>
-      <p:sp>
-        <p:nvSpPr>
-          <p:cNvPr id="15" name="FILL_PLACEHOLDER"/>
-          <p:cNvSpPr/>
-          <p:nvPr/>
-        </p:nvSpPr>
-        <p:spPr>
-          <a:xfrm>
-            <a:off x="4572000" y="2788920"/>
-            <a:ext cx="1600200" cy="457200"/>
-          </a:xfrm>
-          <a:prstGeom prst="roundRect">
-            <a:avLst>
-              <a:gd name="adj" fmla="val 8000"/>
-            </a:avLst>
-          </a:prstGeom>
-          <a:solidFill>
-            <a:srgbClr val="FBEFC4"/>
-          </a:solidFill>
-          <a:ln w="19050">
-            <a:solidFill>
-              <a:srgbClr val="E8B931"/>
-            </a:solidFill>
-          </a:ln>
-          <a:effectLst/>
-        </p:spPr>
-        <p:txBody>
-          <a:bodyPr rtlCol="0" anchor="ctr" lIns="109728" rIns="109728" tIns="36576" bIns="36576" wrap="square"/>
-          <a:lstStyle/>
-          <a:p>
-            <a:pPr algn="ctr"/>
-            <a:r>
-              <a:rPr sz="2000" b="1">
-                <a:solidFill>
-                  <a:srgbClr val="1B2430"/>
-                </a:solidFill>
-                <a:latin typeface="Calibri"/>
-              </a:rPr>
-              <a:t>[FILL: K]</a:t>
-            </a:r>
-          </a:p>
-        </p:txBody>
-      </p:sp>
-      <p:sp>
-        <p:nvSpPr>
-          <p:cNvPr id="16" name="TextBox 15"/>
+              <a:rPr sz="5600" b="1" i="0">
+                <a:solidFill>
+                  <a:srgbClr val="E8B931"/>
+                </a:solidFill>
+                <a:latin typeface="Calibri"/>
+              </a:rPr>
+              <a:t>2,500</a:t>
+            </a:r>
+          </a:p>
+        </p:txBody>
+      </p:sp>
+      <p:sp>
+        <p:nvSpPr>
+          <p:cNvPr id="14" name="TextBox 13"/>
           <p:cNvSpPr txBox="1"/>
           <p:nvPr/>
         </p:nvSpPr>
         <p:spPr>
           <a:xfrm>
-            <a:off x="6217920" y="2788920"/>
-            <a:ext cx="1581912" cy="457200"/>
+            <a:off x="4572000" y="2971800"/>
+            <a:ext cx="3182112" cy="640080"/>
           </a:xfrm>
           <a:prstGeom prst="rect">
             <a:avLst/>
@@ -9262,7 +9198,7 @@
           <a:noFill/>
         </p:spPr>
         <p:txBody>
-          <a:bodyPr wrap="square" anchor="ctr" lIns="0" rIns="0" tIns="0" bIns="0">
+          <a:bodyPr wrap="square" anchor="t" lIns="0" rIns="0" tIns="0" bIns="0">
             <a:spAutoFit/>
           </a:bodyPr>
           <a:lstStyle/>
@@ -9273,27 +9209,27 @@
               </a:lnSpc>
             </a:pPr>
             <a:r>
-              <a:rPr sz="2000" b="0" i="0">
-                <a:solidFill>
-                  <a:srgbClr val="1B2430"/>
-                </a:solidFill>
-                <a:latin typeface="Calibri"/>
-              </a:rPr>
-              <a:t>relations</a:t>
-            </a:r>
-          </a:p>
-        </p:txBody>
-      </p:sp>
-      <p:sp>
-        <p:nvSpPr>
-          <p:cNvPr id="17" name="Rounded Rectangle 16"/>
+              <a:rPr sz="1600" b="0" i="0">
+                <a:solidFill>
+                  <a:srgbClr val="6B7684"/>
+                </a:solidFill>
+                <a:latin typeface="Calibri"/>
+              </a:rPr>
+              <a:t>sentences · 25 relations</a:t>
+            </a:r>
+          </a:p>
+        </p:txBody>
+      </p:sp>
+      <p:sp>
+        <p:nvSpPr>
+          <p:cNvPr id="15" name="Rounded Rectangle 14"/>
           <p:cNvSpPr/>
           <p:nvPr/>
         </p:nvSpPr>
         <p:spPr>
           <a:xfrm>
             <a:off x="8046720" y="1554480"/>
-            <a:ext cx="3593592" cy="2011680"/>
+            <a:ext cx="3593592" cy="2103120"/>
           </a:xfrm>
           <a:prstGeom prst="roundRect">
             <a:avLst>
@@ -9318,14 +9254,14 @@
       </p:sp>
       <p:sp>
         <p:nvSpPr>
-          <p:cNvPr id="18" name="Rectangle 17"/>
+          <p:cNvPr id="16" name="Rectangle 15"/>
           <p:cNvSpPr/>
           <p:nvPr/>
         </p:nvSpPr>
         <p:spPr>
           <a:xfrm>
             <a:off x="8046720" y="1783080"/>
-            <a:ext cx="64008" cy="1554480"/>
+            <a:ext cx="64008" cy="1645920"/>
           </a:xfrm>
           <a:prstGeom prst="rect">
             <a:avLst/>
@@ -9348,7 +9284,7 @@
       </p:sp>
       <p:sp>
         <p:nvSpPr>
-          <p:cNvPr id="19" name="TextBox 18"/>
+          <p:cNvPr id="17" name="TextBox 16"/>
           <p:cNvSpPr txBox="1"/>
           <p:nvPr/>
         </p:nvSpPr>
@@ -9387,13 +9323,13 @@
       </p:sp>
       <p:sp>
         <p:nvSpPr>
-          <p:cNvPr id="20" name="TextBox 19"/>
+          <p:cNvPr id="18" name="TextBox 17"/>
           <p:cNvSpPr txBox="1"/>
           <p:nvPr/>
         </p:nvSpPr>
         <p:spPr>
           <a:xfrm>
-            <a:off x="8321040" y="2240280"/>
+            <a:off x="8321040" y="2331720"/>
             <a:ext cx="3182112" cy="1097280"/>
           </a:xfrm>
           <a:prstGeom prst="rect">
@@ -9426,14 +9362,14 @@
       </p:sp>
       <p:sp>
         <p:nvSpPr>
-          <p:cNvPr id="21" name="TextBox 20"/>
+          <p:cNvPr id="19" name="TextBox 18"/>
           <p:cNvSpPr txBox="1"/>
           <p:nvPr/>
         </p:nvSpPr>
         <p:spPr>
           <a:xfrm>
-            <a:off x="548640" y="3749039"/>
-            <a:ext cx="11094415" cy="548640"/>
+            <a:off x="548640" y="3931920"/>
+            <a:ext cx="11094415" cy="365760"/>
           </a:xfrm>
           <a:prstGeom prst="rect">
             <a:avLst/>
@@ -9441,7 +9377,7 @@
           <a:noFill/>
         </p:spPr>
         <p:txBody>
-          <a:bodyPr wrap="square" anchor="ctr" lIns="0" rIns="0" tIns="0" bIns="0">
+          <a:bodyPr wrap="square" anchor="t" lIns="0" rIns="0" tIns="0" bIns="0">
             <a:spAutoFit/>
           </a:bodyPr>
           <a:lstStyle/>
@@ -9452,71 +9388,26 @@
               </a:lnSpc>
             </a:pPr>
             <a:r>
-              <a:rPr sz="2000" b="1" i="0">
-                <a:solidFill>
-                  <a:srgbClr val="6B7684"/>
-                </a:solidFill>
-                <a:latin typeface="Calibri"/>
-              </a:rPr>
-              <a:t>SemEval example:  </a:t>
-            </a:r>
-            <a:r>
-              <a:rPr sz="2000" b="0" i="0">
-                <a:solidFill>
-                  <a:srgbClr val="1B2430"/>
-                </a:solidFill>
-                <a:latin typeface="Calibri"/>
-              </a:rPr>
-              <a:t>“financial </a:t>
-            </a:r>
-            <a:r>
-              <a:rPr sz="2000" b="1" i="0">
+              <a:rPr sz="1600" b="1" i="0">
                 <a:solidFill>
                   <a:srgbClr val="4C8BF5"/>
                 </a:solidFill>
                 <a:latin typeface="Calibri"/>
               </a:rPr>
-              <a:t>stress</a:t>
-            </a:r>
-            <a:r>
-              <a:rPr sz="2000" b="0" i="0">
-                <a:solidFill>
-                  <a:srgbClr val="1B2430"/>
-                </a:solidFill>
-                <a:latin typeface="Calibri"/>
-              </a:rPr>
-              <a:t> is one of the main causes of </a:t>
-            </a:r>
-            <a:r>
-              <a:rPr sz="2000" b="1" i="0">
-                <a:solidFill>
-                  <a:srgbClr val="4C8BF5"/>
-                </a:solidFill>
-                <a:latin typeface="Calibri"/>
-              </a:rPr>
-              <a:t>divorce</a:t>
-            </a:r>
-            <a:r>
-              <a:rPr sz="2000" b="0" i="0">
-                <a:solidFill>
-                  <a:srgbClr val="6B7684"/>
-                </a:solidFill>
-                <a:latin typeface="Calibri"/>
-              </a:rPr>
-              <a:t>.”  → cause-effect</a:t>
+              <a:t>RESULTS (F1, %)</a:t>
             </a:r>
           </a:p>
         </p:txBody>
       </p:sp>
       <p:cxnSp>
         <p:nvCxnSpPr>
-          <p:cNvPr id="22" name="Connector 21"/>
+          <p:cNvPr id="20" name="Connector 19"/>
           <p:cNvCxnSpPr/>
           <p:nvPr/>
         </p:nvCxnSpPr>
         <p:spPr>
           <a:xfrm>
-            <a:off x="548640" y="4434840"/>
+            <a:off x="548640" y="4343400"/>
             <a:ext cx="11094415" cy="0"/>
           </a:xfrm>
           <a:prstGeom prst="line">
@@ -9531,14 +9422,14 @@
       </p:cxnSp>
       <p:sp>
         <p:nvSpPr>
-          <p:cNvPr id="23" name="TextBox 22"/>
+          <p:cNvPr id="21" name="TextBox 20"/>
           <p:cNvSpPr txBox="1"/>
           <p:nvPr/>
         </p:nvSpPr>
         <p:spPr>
           <a:xfrm>
-            <a:off x="548640" y="4572000"/>
-            <a:ext cx="3593592" cy="777240"/>
+            <a:off x="548640" y="4526280"/>
+            <a:ext cx="3593592" cy="868680"/>
           </a:xfrm>
           <a:prstGeom prst="rect">
             <a:avLst/>
@@ -9557,7 +9448,7 @@
               </a:lnSpc>
             </a:pPr>
             <a:r>
-              <a:rPr sz="4800" b="1" i="0">
+              <a:rPr sz="5600" b="1" i="0">
                 <a:solidFill>
                   <a:srgbClr val="E8B931"/>
                 </a:solidFill>
@@ -9570,13 +9461,13 @@
       </p:sp>
       <p:sp>
         <p:nvSpPr>
-          <p:cNvPr id="24" name="TextBox 23"/>
+          <p:cNvPr id="22" name="TextBox 21"/>
           <p:cNvSpPr txBox="1"/>
           <p:nvPr/>
         </p:nvSpPr>
         <p:spPr>
           <a:xfrm>
-            <a:off x="548640" y="5349240"/>
+            <a:off x="548640" y="5440680"/>
             <a:ext cx="3593592" cy="457200"/>
           </a:xfrm>
           <a:prstGeom prst="rect">
@@ -9609,14 +9500,14 @@
       </p:sp>
       <p:sp>
         <p:nvSpPr>
-          <p:cNvPr id="25" name="TextBox 24"/>
+          <p:cNvPr id="23" name="TextBox 22"/>
           <p:cNvSpPr txBox="1"/>
           <p:nvPr/>
         </p:nvSpPr>
         <p:spPr>
           <a:xfrm>
-            <a:off x="4297680" y="4572000"/>
-            <a:ext cx="3593592" cy="777240"/>
+            <a:off x="4297680" y="4526280"/>
+            <a:ext cx="3593592" cy="868680"/>
           </a:xfrm>
           <a:prstGeom prst="rect">
             <a:avLst/>
@@ -9635,7 +9526,7 @@
               </a:lnSpc>
             </a:pPr>
             <a:r>
-              <a:rPr sz="4800" b="1" i="0">
+              <a:rPr sz="5600" b="1" i="0">
                 <a:solidFill>
                   <a:srgbClr val="E8B931"/>
                 </a:solidFill>
@@ -9648,13 +9539,13 @@
       </p:sp>
       <p:sp>
         <p:nvSpPr>
-          <p:cNvPr id="26" name="TextBox 25"/>
+          <p:cNvPr id="24" name="TextBox 23"/>
           <p:cNvSpPr txBox="1"/>
           <p:nvPr/>
         </p:nvSpPr>
         <p:spPr>
           <a:xfrm>
-            <a:off x="4297680" y="5349240"/>
+            <a:off x="4297680" y="5440680"/>
             <a:ext cx="3593592" cy="457200"/>
           </a:xfrm>
           <a:prstGeom prst="rect">
@@ -9687,14 +9578,14 @@
       </p:sp>
       <p:sp>
         <p:nvSpPr>
-          <p:cNvPr id="27" name="TextBox 26"/>
+          <p:cNvPr id="25" name="TextBox 24"/>
           <p:cNvSpPr txBox="1"/>
           <p:nvPr/>
         </p:nvSpPr>
         <p:spPr>
           <a:xfrm>
-            <a:off x="8046720" y="4572000"/>
-            <a:ext cx="3593592" cy="777240"/>
+            <a:off x="8046720" y="4526280"/>
+            <a:ext cx="3593592" cy="868680"/>
           </a:xfrm>
           <a:prstGeom prst="rect">
             <a:avLst/>
@@ -9713,7 +9604,7 @@
               </a:lnSpc>
             </a:pPr>
             <a:r>
-              <a:rPr sz="4800" b="1" i="0">
+              <a:rPr sz="5600" b="1" i="0">
                 <a:solidFill>
                   <a:srgbClr val="E8B931"/>
                 </a:solidFill>
@@ -9726,13 +9617,13 @@
       </p:sp>
       <p:sp>
         <p:nvSpPr>
-          <p:cNvPr id="28" name="TextBox 27"/>
+          <p:cNvPr id="26" name="TextBox 25"/>
           <p:cNvSpPr txBox="1"/>
           <p:nvPr/>
         </p:nvSpPr>
         <p:spPr>
           <a:xfrm>
-            <a:off x="8046720" y="5349240"/>
+            <a:off x="8046720" y="5440680"/>
             <a:ext cx="3593592" cy="457200"/>
           </a:xfrm>
           <a:prstGeom prst="rect">
@@ -10556,7 +10447,7 @@
         <p:spPr>
           <a:xfrm>
             <a:off x="548640" y="4663440"/>
-            <a:ext cx="2926080" cy="548640"/>
+            <a:ext cx="3108960" cy="822960"/>
           </a:xfrm>
           <a:prstGeom prst="rect">
             <a:avLst/>
@@ -10588,57 +10479,14 @@
       </p:sp>
       <p:sp>
         <p:nvSpPr>
-          <p:cNvPr id="25" name="FILL_PLACEHOLDER"/>
-          <p:cNvSpPr/>
-          <p:nvPr/>
-        </p:nvSpPr>
-        <p:spPr>
-          <a:xfrm>
-            <a:off x="3474720" y="4663440"/>
-            <a:ext cx="2377440" cy="548640"/>
-          </a:xfrm>
-          <a:prstGeom prst="roundRect">
-            <a:avLst>
-              <a:gd name="adj" fmla="val 8000"/>
-            </a:avLst>
-          </a:prstGeom>
-          <a:solidFill>
-            <a:srgbClr val="FBEFC4"/>
-          </a:solidFill>
-          <a:ln w="19050">
-            <a:solidFill>
-              <a:srgbClr val="E8B931"/>
-            </a:solidFill>
-          </a:ln>
-          <a:effectLst/>
-        </p:spPr>
-        <p:txBody>
-          <a:bodyPr rtlCol="0" anchor="ctr" lIns="109728" rIns="109728" tIns="36576" bIns="36576" wrap="square"/>
-          <a:lstStyle/>
-          <a:p>
-            <a:pPr algn="ctr"/>
-            <a:r>
-              <a:rPr sz="2000" b="1">
-                <a:solidFill>
-                  <a:srgbClr val="1B2430"/>
-                </a:solidFill>
-                <a:latin typeface="Calibri"/>
-              </a:rPr>
-              <a:t>[FILL: N labelled]</a:t>
-            </a:r>
-          </a:p>
-        </p:txBody>
-      </p:sp>
-      <p:sp>
-        <p:nvSpPr>
-          <p:cNvPr id="26" name="TextBox 25"/>
+          <p:cNvPr id="25" name="TextBox 24"/>
           <p:cNvSpPr txBox="1"/>
           <p:nvPr/>
         </p:nvSpPr>
         <p:spPr>
           <a:xfrm>
-            <a:off x="5989320" y="4663440"/>
-            <a:ext cx="5669280" cy="548640"/>
+            <a:off x="3657600" y="4663440"/>
+            <a:ext cx="2377440" cy="822960"/>
           </a:xfrm>
           <a:prstGeom prst="rect">
             <a:avLst/>
@@ -10657,27 +10505,27 @@
               </a:lnSpc>
             </a:pPr>
             <a:r>
-              <a:rPr sz="2000" b="0" i="0">
-                <a:solidFill>
-                  <a:srgbClr val="1B2430"/>
-                </a:solidFill>
-                <a:latin typeface="Calibri"/>
-              </a:rPr>
-              <a:t>sentences</a:t>
-            </a:r>
-          </a:p>
-        </p:txBody>
-      </p:sp>
-      <p:sp>
-        <p:nvSpPr>
-          <p:cNvPr id="27" name="TextBox 26"/>
+              <a:rPr sz="4800" b="1" i="0">
+                <a:solidFill>
+                  <a:srgbClr val="E8B931"/>
+                </a:solidFill>
+                <a:latin typeface="Calibri"/>
+              </a:rPr>
+              <a:t>0 / 100</a:t>
+            </a:r>
+          </a:p>
+        </p:txBody>
+      </p:sp>
+      <p:sp>
+        <p:nvSpPr>
+          <p:cNvPr id="26" name="TextBox 25"/>
           <p:cNvSpPr txBox="1"/>
           <p:nvPr/>
         </p:nvSpPr>
         <p:spPr>
           <a:xfrm>
-            <a:off x="548640" y="5349240"/>
-            <a:ext cx="11094415" cy="548640"/>
+            <a:off x="6126479" y="4663440"/>
+            <a:ext cx="5486400" cy="822960"/>
           </a:xfrm>
           <a:prstGeom prst="rect">
             <a:avLst/>
@@ -10696,13 +10544,13 @@
               </a:lnSpc>
             </a:pPr>
             <a:r>
-              <a:rPr sz="2000" b="0" i="1">
+              <a:rPr sz="2000" b="0" i="0">
                 <a:solidFill>
                   <a:srgbClr val="6B7684"/>
                 </a:solidFill>
                 <a:latin typeface="Calibri"/>
               </a:rPr>
-              <a:t>If none yet: “The annotation sheet is ready, and labelling starts next.”</a:t>
+              <a:t>sentences labelled. The sheet is ready, and labelling starts next.</a:t>
             </a:r>
           </a:p>
         </p:txBody>
@@ -11253,57 +11101,14 @@
                 </a:solidFill>
                 <a:latin typeface="Calibri"/>
               </a:rPr>
-              <a:t>Own dataset is built and</a:t>
-            </a:r>
-          </a:p>
-        </p:txBody>
-      </p:sp>
-      <p:sp>
-        <p:nvSpPr>
-          <p:cNvPr id="17" name="FILL_PLACEHOLDER"/>
-          <p:cNvSpPr/>
-          <p:nvPr/>
-        </p:nvSpPr>
-        <p:spPr>
-          <a:xfrm>
-            <a:off x="4775282" y="3913631"/>
-            <a:ext cx="4572000" cy="548640"/>
-          </a:xfrm>
-          <a:prstGeom prst="roundRect">
-            <a:avLst>
-              <a:gd name="adj" fmla="val 8000"/>
-            </a:avLst>
-          </a:prstGeom>
-          <a:solidFill>
-            <a:srgbClr val="FBEFC4"/>
-          </a:solidFill>
-          <a:ln w="19050">
-            <a:solidFill>
-              <a:srgbClr val="E8B931"/>
-            </a:solidFill>
-          </a:ln>
-          <a:effectLst/>
-        </p:spPr>
-        <p:txBody>
-          <a:bodyPr rtlCol="0" anchor="ctr" lIns="109728" rIns="109728" tIns="36576" bIns="36576" wrap="square"/>
-          <a:lstStyle/>
-          <a:p>
-            <a:pPr algn="ctr"/>
-            <a:r>
-              <a:rPr sz="1800" b="1">
-                <a:solidFill>
-                  <a:srgbClr val="1B2430"/>
-                </a:solidFill>
-                <a:latin typeface="Calibri"/>
-              </a:rPr>
-              <a:t>[FILL: partly labelled / ready to label]</a:t>
+              <a:t>Own dataset is built and ready to label</a:t>
             </a:r>
           </a:p>
         </p:txBody>
       </p:sp>
       <p:cxnSp>
         <p:nvCxnSpPr>
-          <p:cNvPr id="18" name="Connector 17"/>
+          <p:cNvPr id="17" name="Connector 16"/>
           <p:cNvCxnSpPr/>
           <p:nvPr/>
         </p:nvCxnSpPr>
@@ -11324,7 +11129,7 @@
       </p:cxnSp>
       <p:sp>
         <p:nvSpPr>
-          <p:cNvPr id="19" name="TextBox 18"/>
+          <p:cNvPr id="18" name="TextBox 17"/>
           <p:cNvSpPr txBox="1"/>
           <p:nvPr/>
         </p:nvSpPr>

</xml_diff>